<commit_message>
[BASTION] - Actualiza documento y presentacion: incluyen la aplicacion web (Pyodide, demo en vivo)
</commit_message>
<xml_diff>
--- a/presentacion/Presentacion_BASTION.pptx
+++ b/presentacion/Presentacion_BASTION.pptx
@@ -15,9 +15,10 @@
     <p:sldId id="263" r:id="rId9"/>
     <p:sldId id="264" r:id="rId10"/>
     <p:sldId id="265" r:id="rId11"/>
+    <p:sldId id="266" r:id="rId12"/>
   </p:sldIdLst>
   <p:notesMasterIdLst>
-    <p:notesMasterId r:id="rId12"/>
+    <p:notesMasterId r:id="rId13"/>
   </p:notesMasterIdLst>
   <p:sldSz cx="12192000" cy="6858000"/>
   <p:notesSz cx="6858000" cy="12192000"/>
@@ -623,6 +624,94 @@
             <a:fld id="{F7021451-1387-4CA6-816F-3879F97B5CBC}" type="slidenum">
               <a:rPr lang="en-US"/>
               <a:t>10</a:t>
+            </a:fld>
+            <a:endParaRPr lang="en-US"/>
+          </a:p>
+        </p:txBody>
+      </p:sp>
+    </p:spTree>
+    <p:extLst>
+      <p:ext uri="{BB962C8B-B14F-4D97-AF65-F5344CB8AC3E}">
+        <p14:creationId xmlns:p14="http://schemas.microsoft.com/office/powerpoint/2010/main" val="1024086991"/>
+      </p:ext>
+    </p:extLst>
+  </p:cSld>
+  <p:clrMapOvr>
+    <a:masterClrMapping/>
+  </p:clrMapOvr>
+</p:notes>
+</file>
+
+<file path=ppt/notesSlides/notesSlide11.xml><?xml version="1.0" encoding="utf-8"?>
+<p:notes xmlns:a="http://schemas.openxmlformats.org/drawingml/2006/main" xmlns:r="http://schemas.openxmlformats.org/officeDocument/2006/relationships" xmlns:p="http://schemas.openxmlformats.org/presentationml/2006/main">
+  <p:cSld>
+    <p:spTree>
+      <p:nvGrpSpPr>
+        <p:cNvPr id="1" name=""/>
+        <p:cNvGrpSpPr/>
+        <p:nvPr/>
+      </p:nvGrpSpPr>
+      <p:grpSpPr>
+        <a:xfrm>
+          <a:off x="0" y="0"/>
+          <a:ext cx="0" cy="0"/>
+          <a:chOff x="0" y="0"/>
+          <a:chExt cx="0" cy="0"/>
+        </a:xfrm>
+      </p:grpSpPr>
+      <p:sp>
+        <p:nvSpPr>
+          <p:cNvPr id="2" name="Slide Image Placeholder 1"/>
+          <p:cNvSpPr>
+            <a:spLocks noGrp="1" noRot="1" noChangeAspect="1"/>
+          </p:cNvSpPr>
+          <p:nvPr>
+            <p:ph type="sldImg"/>
+          </p:nvPr>
+        </p:nvSpPr>
+        <p:spPr/>
+      </p:sp>
+      <p:sp>
+        <p:nvSpPr>
+          <p:cNvPr id="3" name="Notes Placeholder 2"/>
+          <p:cNvSpPr>
+            <a:spLocks noGrp="1"/>
+          </p:cNvSpPr>
+          <p:nvPr>
+            <p:ph type="body" idx="1"/>
+          </p:nvPr>
+        </p:nvSpPr>
+        <p:spPr/>
+        <p:txBody>
+          <a:bodyPr/>
+          <a:lstStyle/>
+          <a:p>
+            <a:r>
+              <a:rPr lang="en-US" dirty="0"/>
+              <a:t/>
+            </a:r>
+            <a:endParaRPr lang="en-US" dirty="0"/>
+          </a:p>
+        </p:txBody>
+      </p:sp>
+      <p:sp>
+        <p:nvSpPr>
+          <p:cNvPr id="4" name="Slide Number Placeholder 3"/>
+          <p:cNvSpPr>
+            <a:spLocks noGrp="1"/>
+          </p:cNvSpPr>
+          <p:nvPr>
+            <p:ph type="sldNum" sz="quarter" idx="10"/>
+          </p:nvPr>
+        </p:nvSpPr>
+        <p:spPr/>
+        <p:txBody>
+          <a:bodyPr/>
+          <a:lstStyle/>
+          <a:p>
+            <a:fld id="{F7021451-1387-4CA6-816F-3879F97B5CBC}" type="slidenum">
+              <a:rPr lang="en-US"/>
+              <a:t>11</a:t>
             </a:fld>
             <a:endParaRPr lang="en-US"/>
           </a:p>
@@ -2020,6 +2109,611 @@
     <p:bg>
       <p:bgPr>
         <a:solidFill>
+          <a:srgbClr val="FFFFFF"/>
+        </a:solidFill>
+      </p:bgPr>
+    </p:bg>
+    <p:spTree>
+      <p:nvGrpSpPr>
+        <p:cNvPr id="1" name=""/>
+        <p:cNvGrpSpPr/>
+        <p:nvPr/>
+      </p:nvGrpSpPr>
+      <p:grpSpPr>
+        <a:xfrm>
+          <a:off x="0" y="0"/>
+          <a:ext cx="0" cy="0"/>
+          <a:chOff x="0" y="0"/>
+          <a:chExt cx="0" cy="0"/>
+        </a:xfrm>
+      </p:grpSpPr>
+      <p:sp>
+        <p:nvSpPr>
+          <p:cNvPr id="2" name="Text 0"/>
+          <p:cNvSpPr/>
+          <p:nvPr/>
+        </p:nvSpPr>
+        <p:spPr>
+          <a:xfrm>
+            <a:off x="640080" y="411480"/>
+            <a:ext cx="10972800" cy="822960"/>
+          </a:xfrm>
+          <a:prstGeom prst="rect">
+            <a:avLst/>
+          </a:prstGeom>
+          <a:noFill/>
+          <a:ln/>
+        </p:spPr>
+        <p:txBody>
+          <a:bodyPr wrap="square" lIns="0" tIns="0" rIns="0" bIns="0" rtlCol="0" anchor="ctr"/>
+          <a:lstStyle/>
+          <a:p>
+            <a:pPr algn="l" indent="0" marL="0">
+              <a:buNone/>
+            </a:pPr>
+            <a:r>
+              <a:rPr lang="en-US" sz="3000" b="1" dirty="0">
+                <a:solidFill>
+                  <a:srgbClr val="7A1F3D"/>
+                </a:solidFill>
+                <a:latin typeface="Cambria" pitchFamily="34" charset="0"/>
+                <a:ea typeface="Cambria" pitchFamily="34" charset="-122"/>
+                <a:cs typeface="Cambria" pitchFamily="34" charset="-120"/>
+              </a:rPr>
+              <a:t>La aplicacion web en vivo</a:t>
+            </a:r>
+            <a:endParaRPr lang="en-US" sz="3000" dirty="0"/>
+          </a:p>
+        </p:txBody>
+      </p:sp>
+      <p:sp>
+        <p:nvSpPr>
+          <p:cNvPr id="3" name="Text 1"/>
+          <p:cNvSpPr/>
+          <p:nvPr/>
+        </p:nvSpPr>
+        <p:spPr>
+          <a:xfrm>
+            <a:off x="640080" y="1325880"/>
+            <a:ext cx="10881360" cy="640080"/>
+          </a:xfrm>
+          <a:prstGeom prst="rect">
+            <a:avLst/>
+          </a:prstGeom>
+          <a:noFill/>
+          <a:ln/>
+        </p:spPr>
+        <p:txBody>
+          <a:bodyPr wrap="square" lIns="0" tIns="0" rIns="0" bIns="0" rtlCol="0" anchor="t"/>
+          <a:lstStyle/>
+          <a:p>
+            <a:pPr indent="0" marL="0">
+              <a:buNone/>
+            </a:pPr>
+            <a:r>
+              <a:rPr lang="en-US" sz="1600" dirty="0">
+                <a:solidFill>
+                  <a:srgbClr val="23232B"/>
+                </a:solidFill>
+                <a:latin typeface="Calibri" pitchFamily="34" charset="0"/>
+                <a:ea typeface="Calibri" pitchFamily="34" charset="-122"/>
+                <a:cs typeface="Calibri" pitchFamily="34" charset="-120"/>
+              </a:rPr>
+              <a:t>El mismo codigo de bastion.py se ejecuta dentro del navegador con Pyodide. La docente puede entrar, usar la herramienta y ver el codigo Python corriendo por dentro.</a:t>
+            </a:r>
+            <a:endParaRPr lang="en-US" sz="1600" dirty="0"/>
+          </a:p>
+        </p:txBody>
+      </p:sp>
+      <p:sp>
+        <p:nvSpPr>
+          <p:cNvPr id="4" name="Shape 2"/>
+          <p:cNvSpPr/>
+          <p:nvPr/>
+        </p:nvSpPr>
+        <p:spPr>
+          <a:xfrm>
+            <a:off x="640080" y="2194560"/>
+            <a:ext cx="3502152" cy="2286000"/>
+          </a:xfrm>
+          <a:prstGeom prst="roundRect">
+            <a:avLst>
+              <a:gd name="adj" fmla="val 3600"/>
+            </a:avLst>
+          </a:prstGeom>
+          <a:solidFill>
+            <a:srgbClr val="F7F1F4"/>
+          </a:solidFill>
+          <a:ln/>
+          <a:effectLst>
+            <a:outerShdw sx="100000" sy="100000" kx="0" ky="0" algn="bl" rotWithShape="0" blurRad="88900" dist="38100" dir="5400000">
+              <a:srgbClr val="000000">
+                <a:alpha val="16000"/>
+              </a:srgbClr>
+            </a:outerShdw>
+          </a:effectLst>
+        </p:spPr>
+      </p:sp>
+      <p:sp>
+        <p:nvSpPr>
+          <p:cNvPr id="5" name="Text 3"/>
+          <p:cNvSpPr/>
+          <p:nvPr/>
+        </p:nvSpPr>
+        <p:spPr>
+          <a:xfrm>
+            <a:off x="932688" y="2487168"/>
+            <a:ext cx="2926080" cy="457200"/>
+          </a:xfrm>
+          <a:prstGeom prst="rect">
+            <a:avLst/>
+          </a:prstGeom>
+          <a:noFill/>
+          <a:ln/>
+        </p:spPr>
+        <p:txBody>
+          <a:bodyPr wrap="square" lIns="0" tIns="0" rIns="0" bIns="0" rtlCol="0" anchor="ctr"/>
+          <a:lstStyle/>
+          <a:p>
+            <a:pPr indent="0" marL="0">
+              <a:buNone/>
+            </a:pPr>
+            <a:r>
+              <a:rPr lang="en-US" sz="1800" b="1" dirty="0">
+                <a:solidFill>
+                  <a:srgbClr val="7A1F3D"/>
+                </a:solidFill>
+                <a:latin typeface="Cambria" pitchFamily="34" charset="0"/>
+                <a:ea typeface="Cambria" pitchFamily="34" charset="-122"/>
+                <a:cs typeface="Cambria" pitchFamily="34" charset="-120"/>
+              </a:rPr>
+              <a:t>Python real</a:t>
+            </a:r>
+            <a:endParaRPr lang="en-US" sz="1800" dirty="0"/>
+          </a:p>
+        </p:txBody>
+      </p:sp>
+      <p:sp>
+        <p:nvSpPr>
+          <p:cNvPr id="6" name="Text 4"/>
+          <p:cNvSpPr/>
+          <p:nvPr/>
+        </p:nvSpPr>
+        <p:spPr>
+          <a:xfrm>
+            <a:off x="932688" y="3035808"/>
+            <a:ext cx="2944368" cy="1280160"/>
+          </a:xfrm>
+          <a:prstGeom prst="rect">
+            <a:avLst/>
+          </a:prstGeom>
+          <a:noFill/>
+          <a:ln/>
+        </p:spPr>
+        <p:txBody>
+          <a:bodyPr wrap="square" lIns="0" tIns="0" rIns="0" bIns="0" rtlCol="0" anchor="t"/>
+          <a:lstStyle/>
+          <a:p>
+            <a:pPr indent="0" marL="0">
+              <a:buNone/>
+            </a:pPr>
+            <a:r>
+              <a:rPr lang="en-US" sz="1300" dirty="0">
+                <a:solidFill>
+                  <a:srgbClr val="23232B"/>
+                </a:solidFill>
+                <a:latin typeface="Calibri" pitchFamily="34" charset="0"/>
+                <a:ea typeface="Calibri" pitchFamily="34" charset="-122"/>
+                <a:cs typeface="Calibri" pitchFamily="34" charset="-120"/>
+              </a:rPr>
+              <a:t>El codigo de bastion.py corre en el navegador mediante Pyodide (WebAssembly); no se reescribe en JavaScript.</a:t>
+            </a:r>
+            <a:endParaRPr lang="en-US" sz="1300" dirty="0"/>
+          </a:p>
+        </p:txBody>
+      </p:sp>
+      <p:sp>
+        <p:nvSpPr>
+          <p:cNvPr id="7" name="Shape 5"/>
+          <p:cNvSpPr/>
+          <p:nvPr/>
+        </p:nvSpPr>
+        <p:spPr>
+          <a:xfrm>
+            <a:off x="4526280" y="2194560"/>
+            <a:ext cx="3502152" cy="2286000"/>
+          </a:xfrm>
+          <a:prstGeom prst="roundRect">
+            <a:avLst>
+              <a:gd name="adj" fmla="val 3600"/>
+            </a:avLst>
+          </a:prstGeom>
+          <a:solidFill>
+            <a:srgbClr val="F7F1F4"/>
+          </a:solidFill>
+          <a:ln/>
+          <a:effectLst>
+            <a:outerShdw sx="100000" sy="100000" kx="0" ky="0" algn="bl" rotWithShape="0" blurRad="88900" dist="38100" dir="5400000">
+              <a:srgbClr val="000000">
+                <a:alpha val="16000"/>
+              </a:srgbClr>
+            </a:outerShdw>
+          </a:effectLst>
+        </p:spPr>
+      </p:sp>
+      <p:sp>
+        <p:nvSpPr>
+          <p:cNvPr id="8" name="Text 6"/>
+          <p:cNvSpPr/>
+          <p:nvPr/>
+        </p:nvSpPr>
+        <p:spPr>
+          <a:xfrm>
+            <a:off x="4818888" y="2487168"/>
+            <a:ext cx="2926080" cy="457200"/>
+          </a:xfrm>
+          <a:prstGeom prst="rect">
+            <a:avLst/>
+          </a:prstGeom>
+          <a:noFill/>
+          <a:ln/>
+        </p:spPr>
+        <p:txBody>
+          <a:bodyPr wrap="square" lIns="0" tIns="0" rIns="0" bIns="0" rtlCol="0" anchor="ctr"/>
+          <a:lstStyle/>
+          <a:p>
+            <a:pPr indent="0" marL="0">
+              <a:buNone/>
+            </a:pPr>
+            <a:r>
+              <a:rPr lang="en-US" sz="1800" b="1" dirty="0">
+                <a:solidFill>
+                  <a:srgbClr val="7A1F3D"/>
+                </a:solidFill>
+                <a:latin typeface="Cambria" pitchFamily="34" charset="0"/>
+                <a:ea typeface="Cambria" pitchFamily="34" charset="-122"/>
+                <a:cs typeface="Cambria" pitchFamily="34" charset="-120"/>
+              </a:rPr>
+              <a:t>Consola en vivo</a:t>
+            </a:r>
+            <a:endParaRPr lang="en-US" sz="1800" dirty="0"/>
+          </a:p>
+        </p:txBody>
+      </p:sp>
+      <p:sp>
+        <p:nvSpPr>
+          <p:cNvPr id="9" name="Text 7"/>
+          <p:cNvSpPr/>
+          <p:nvPr/>
+        </p:nvSpPr>
+        <p:spPr>
+          <a:xfrm>
+            <a:off x="4818888" y="3035808"/>
+            <a:ext cx="2944368" cy="1280160"/>
+          </a:xfrm>
+          <a:prstGeom prst="rect">
+            <a:avLst/>
+          </a:prstGeom>
+          <a:noFill/>
+          <a:ln/>
+        </p:spPr>
+        <p:txBody>
+          <a:bodyPr wrap="square" lIns="0" tIns="0" rIns="0" bIns="0" rtlCol="0" anchor="t"/>
+          <a:lstStyle/>
+          <a:p>
+            <a:pPr indent="0" marL="0">
+              <a:buNone/>
+            </a:pPr>
+            <a:r>
+              <a:rPr lang="en-US" sz="1300" dirty="0">
+                <a:solidFill>
+                  <a:srgbClr val="23232B"/>
+                </a:solidFill>
+                <a:latin typeface="Calibri" pitchFamily="34" charset="0"/>
+                <a:ea typeface="Calibri" pitchFamily="34" charset="-122"/>
+                <a:cs typeface="Calibri" pitchFamily="34" charset="-120"/>
+              </a:rPr>
+              <a:t>Un panel muestra cada llamada a Python y su resultado: transparencia total del funcionamiento.</a:t>
+            </a:r>
+            <a:endParaRPr lang="en-US" sz="1300" dirty="0"/>
+          </a:p>
+        </p:txBody>
+      </p:sp>
+      <p:sp>
+        <p:nvSpPr>
+          <p:cNvPr id="10" name="Shape 8"/>
+          <p:cNvSpPr/>
+          <p:nvPr/>
+        </p:nvSpPr>
+        <p:spPr>
+          <a:xfrm>
+            <a:off x="8412480" y="2194560"/>
+            <a:ext cx="3502152" cy="2286000"/>
+          </a:xfrm>
+          <a:prstGeom prst="roundRect">
+            <a:avLst>
+              <a:gd name="adj" fmla="val 3600"/>
+            </a:avLst>
+          </a:prstGeom>
+          <a:solidFill>
+            <a:srgbClr val="F7F1F4"/>
+          </a:solidFill>
+          <a:ln/>
+          <a:effectLst>
+            <a:outerShdw sx="100000" sy="100000" kx="0" ky="0" algn="bl" rotWithShape="0" blurRad="88900" dist="38100" dir="5400000">
+              <a:srgbClr val="000000">
+                <a:alpha val="16000"/>
+              </a:srgbClr>
+            </a:outerShdw>
+          </a:effectLst>
+        </p:spPr>
+      </p:sp>
+      <p:sp>
+        <p:nvSpPr>
+          <p:cNvPr id="11" name="Text 9"/>
+          <p:cNvSpPr/>
+          <p:nvPr/>
+        </p:nvSpPr>
+        <p:spPr>
+          <a:xfrm>
+            <a:off x="8705088" y="2487168"/>
+            <a:ext cx="2926080" cy="457200"/>
+          </a:xfrm>
+          <a:prstGeom prst="rect">
+            <a:avLst/>
+          </a:prstGeom>
+          <a:noFill/>
+          <a:ln/>
+        </p:spPr>
+        <p:txBody>
+          <a:bodyPr wrap="square" lIns="0" tIns="0" rIns="0" bIns="0" rtlCol="0" anchor="ctr"/>
+          <a:lstStyle/>
+          <a:p>
+            <a:pPr indent="0" marL="0">
+              <a:buNone/>
+            </a:pPr>
+            <a:r>
+              <a:rPr lang="en-US" sz="1800" b="1" dirty="0">
+                <a:solidFill>
+                  <a:srgbClr val="7A1F3D"/>
+                </a:solidFill>
+                <a:latin typeface="Cambria" pitchFamily="34" charset="0"/>
+                <a:ea typeface="Cambria" pitchFamily="34" charset="-122"/>
+                <a:cs typeface="Cambria" pitchFamily="34" charset="-120"/>
+              </a:rPr>
+              <a:t>Sin instalar nada</a:t>
+            </a:r>
+            <a:endParaRPr lang="en-US" sz="1800" dirty="0"/>
+          </a:p>
+        </p:txBody>
+      </p:sp>
+      <p:sp>
+        <p:nvSpPr>
+          <p:cNvPr id="12" name="Text 10"/>
+          <p:cNvSpPr/>
+          <p:nvPr/>
+        </p:nvSpPr>
+        <p:spPr>
+          <a:xfrm>
+            <a:off x="8705088" y="3035808"/>
+            <a:ext cx="2944368" cy="1280160"/>
+          </a:xfrm>
+          <a:prstGeom prst="rect">
+            <a:avLst/>
+          </a:prstGeom>
+          <a:noFill/>
+          <a:ln/>
+        </p:spPr>
+        <p:txBody>
+          <a:bodyPr wrap="square" lIns="0" tIns="0" rIns="0" bIns="0" rtlCol="0" anchor="t"/>
+          <a:lstStyle/>
+          <a:p>
+            <a:pPr indent="0" marL="0">
+              <a:buNone/>
+            </a:pPr>
+            <a:r>
+              <a:rPr lang="en-US" sz="1300" dirty="0">
+                <a:solidFill>
+                  <a:srgbClr val="23232B"/>
+                </a:solidFill>
+                <a:latin typeface="Calibri" pitchFamily="34" charset="0"/>
+                <a:ea typeface="Calibri" pitchFamily="34" charset="-122"/>
+                <a:cs typeface="Calibri" pitchFamily="34" charset="-120"/>
+              </a:rPr>
+              <a:t>Publicada en GitHub Pages; se abre desde cualquier navegador, en escritorio o movil.</a:t>
+            </a:r>
+            <a:endParaRPr lang="en-US" sz="1300" dirty="0"/>
+          </a:p>
+        </p:txBody>
+      </p:sp>
+      <p:sp>
+        <p:nvSpPr>
+          <p:cNvPr id="13" name="Shape 11"/>
+          <p:cNvSpPr/>
+          <p:nvPr/>
+        </p:nvSpPr>
+        <p:spPr>
+          <a:xfrm>
+            <a:off x="2286000" y="5074920"/>
+            <a:ext cx="7616952" cy="777240"/>
+          </a:xfrm>
+          <a:prstGeom prst="roundRect">
+            <a:avLst>
+              <a:gd name="adj" fmla="val 49412"/>
+            </a:avLst>
+          </a:prstGeom>
+          <a:solidFill>
+            <a:srgbClr val="2B2F44"/>
+          </a:solidFill>
+          <a:ln/>
+          <a:effectLst>
+            <a:outerShdw sx="100000" sy="100000" kx="0" ky="0" algn="bl" rotWithShape="0" blurRad="88900" dist="38100" dir="5400000">
+              <a:srgbClr val="000000">
+                <a:alpha val="16000"/>
+              </a:srgbClr>
+            </a:outerShdw>
+          </a:effectLst>
+        </p:spPr>
+      </p:sp>
+      <p:sp>
+        <p:nvSpPr>
+          <p:cNvPr id="14" name="Text 12"/>
+          <p:cNvSpPr/>
+          <p:nvPr/>
+        </p:nvSpPr>
+        <p:spPr>
+          <a:xfrm>
+            <a:off x="2286000" y="5074920"/>
+            <a:ext cx="7616952" cy="777240"/>
+          </a:xfrm>
+          <a:prstGeom prst="rect">
+            <a:avLst/>
+          </a:prstGeom>
+          <a:noFill/>
+          <a:ln/>
+        </p:spPr>
+        <p:txBody>
+          <a:bodyPr wrap="square" lIns="0" tIns="0" rIns="0" bIns="0" rtlCol="0" anchor="ctr"/>
+          <a:lstStyle/>
+          <a:p>
+            <a:pPr algn="ctr" indent="0" marL="0">
+              <a:buNone/>
+            </a:pPr>
+            <a:r>
+              <a:rPr lang="en-US" sz="1500" dirty="0">
+                <a:solidFill>
+                  <a:srgbClr val="C9CCD6"/>
+                </a:solidFill>
+                <a:latin typeface="Calibri" pitchFamily="34" charset="0"/>
+                <a:ea typeface="Calibri" pitchFamily="34" charset="-122"/>
+                <a:cs typeface="Calibri" pitchFamily="34" charset="-120"/>
+              </a:rPr>
+              <a:t>Pruebala en vivo:  </a:t>
+            </a:r>
+            <a:pPr algn="ctr" indent="0" marL="0">
+              <a:buNone/>
+            </a:pPr>
+            <a:r>
+              <a:rPr lang="en-US" sz="1500" b="1" dirty="0">
+                <a:solidFill>
+                  <a:srgbClr val="E8B339"/>
+                </a:solidFill>
+                <a:latin typeface="Calibri" pitchFamily="34" charset="0"/>
+                <a:ea typeface="Calibri" pitchFamily="34" charset="-122"/>
+                <a:cs typeface="Calibri" pitchFamily="34" charset="-120"/>
+              </a:rPr>
+              <a:t>bluenovasas.github.io/bastion-uide/webapp/</a:t>
+            </a:r>
+            <a:endParaRPr lang="en-US" sz="1500" dirty="0"/>
+          </a:p>
+        </p:txBody>
+      </p:sp>
+      <p:sp>
+        <p:nvSpPr>
+          <p:cNvPr id="15" name="Text 13"/>
+          <p:cNvSpPr/>
+          <p:nvPr/>
+        </p:nvSpPr>
+        <p:spPr>
+          <a:xfrm>
+            <a:off x="640080" y="6419088"/>
+            <a:ext cx="8229600" cy="320040"/>
+          </a:xfrm>
+          <a:prstGeom prst="rect">
+            <a:avLst/>
+          </a:prstGeom>
+          <a:noFill/>
+          <a:ln/>
+        </p:spPr>
+        <p:txBody>
+          <a:bodyPr wrap="square" lIns="0" tIns="0" rIns="0" bIns="0" rtlCol="0" anchor="ctr"/>
+          <a:lstStyle/>
+          <a:p>
+            <a:pPr algn="l" indent="0" marL="0">
+              <a:buNone/>
+            </a:pPr>
+            <a:r>
+              <a:rPr lang="en-US" sz="900" b="1" dirty="0">
+                <a:solidFill>
+                  <a:srgbClr val="7A1F3D"/>
+                </a:solidFill>
+                <a:latin typeface="Calibri" pitchFamily="34" charset="0"/>
+                <a:ea typeface="Calibri" pitchFamily="34" charset="-122"/>
+                <a:cs typeface="Calibri" pitchFamily="34" charset="-120"/>
+              </a:rPr>
+              <a:t>BASTION</a:t>
+            </a:r>
+            <a:pPr algn="l" indent="0" marL="0">
+              <a:buNone/>
+            </a:pPr>
+            <a:r>
+              <a:rPr lang="en-US" sz="900" dirty="0">
+                <a:solidFill>
+                  <a:srgbClr val="6B6B73"/>
+                </a:solidFill>
+                <a:latin typeface="Calibri" pitchFamily="34" charset="0"/>
+                <a:ea typeface="Calibri" pitchFamily="34" charset="-122"/>
+                <a:cs typeface="Calibri" pitchFamily="34" charset="-120"/>
+              </a:rPr>
+              <a:t>  ·  Proyecto Integrador  ·  UIDE</a:t>
+            </a:r>
+            <a:endParaRPr lang="en-US" sz="900" dirty="0"/>
+          </a:p>
+        </p:txBody>
+      </p:sp>
+      <p:sp>
+        <p:nvSpPr>
+          <p:cNvPr id="16" name="Text 14"/>
+          <p:cNvSpPr/>
+          <p:nvPr/>
+        </p:nvSpPr>
+        <p:spPr>
+          <a:xfrm>
+            <a:off x="11247120" y="6419088"/>
+            <a:ext cx="548640" cy="320040"/>
+          </a:xfrm>
+          <a:prstGeom prst="rect">
+            <a:avLst/>
+          </a:prstGeom>
+          <a:noFill/>
+          <a:ln/>
+        </p:spPr>
+        <p:txBody>
+          <a:bodyPr wrap="square" lIns="0" tIns="0" rIns="0" bIns="0" rtlCol="0" anchor="ctr"/>
+          <a:lstStyle/>
+          <a:p>
+            <a:pPr algn="r" indent="0" marL="0">
+              <a:buNone/>
+            </a:pPr>
+            <a:r>
+              <a:rPr lang="en-US" sz="900" dirty="0">
+                <a:solidFill>
+                  <a:srgbClr val="6B6B73"/>
+                </a:solidFill>
+                <a:latin typeface="Calibri" pitchFamily="34" charset="0"/>
+                <a:ea typeface="Calibri" pitchFamily="34" charset="-122"/>
+                <a:cs typeface="Calibri" pitchFamily="34" charset="-120"/>
+              </a:rPr>
+              <a:t>10</a:t>
+            </a:r>
+            <a:endParaRPr lang="en-US" sz="900" dirty="0"/>
+          </a:p>
+        </p:txBody>
+      </p:sp>
+    </p:spTree>
+  </p:cSld>
+  <p:clrMapOvr>
+    <a:masterClrMapping/>
+  </p:clrMapOvr>
+</p:sld>
+</file>
+
+<file path=ppt/slides/slide11.xml><?xml version="1.0" encoding="utf-8"?>
+<p:sld xmlns:a="http://schemas.openxmlformats.org/drawingml/2006/main" xmlns:r="http://schemas.openxmlformats.org/officeDocument/2006/relationships" xmlns:p="http://schemas.openxmlformats.org/presentationml/2006/main">
+  <p:cSld name="Slide 11">
+    <p:bg>
+      <p:bgPr>
+        <a:solidFill>
           <a:srgbClr val="7A1F3D"/>
         </a:solidFill>
       </p:bgPr>

</xml_diff>